<commit_message>
Livrables du jour 4 : prototype, pitch, présentation et business plan
Co-Authored-By: Claude Opus 5.5 <noreply@anthropic.com>
Claude-Session: https://claude.ai/code/session_013D7uRxLFz2dHeA6eheZQbo
</commit_message>
<xml_diff>
--- a/J3_IDDIC_JOUR_3.pptx
+++ b/J3_IDDIC_JOUR_3.pptx
@@ -317,6 +317,11 @@
       </a:defRPr>
     </a:lvl9pPr>
   </p:defaultTextStyle>
+  <p:extLst>
+    <p:ext uri="{EFAFB233-063F-42B5-8137-9DF3F51BA10A}">
+      <p15:sldGuideLst xmlns:p15="http://schemas.microsoft.com/office/powerpoint/2012/main"/>
+    </p:ext>
+  </p:extLst>
 </p:presentation>
 </file>
 
@@ -8162,15 +8167,26 @@
           <a:bodyPr lIns="45718" tIns="45718" rIns="45718" bIns="45718"/>
           <a:lstStyle/>
           <a:p>
-            <a:pPr>
-              <a:defRPr>
-                <a:latin typeface="+mn-lt"/>
-                <a:ea typeface="+mn-ea"/>
-                <a:cs typeface="+mn-cs"/>
-                <a:sym typeface="Calibri"/>
-              </a:defRPr>
-            </a:pPr>
-            <a:endParaRPr/>
+            <a:pPr lvl="0"/>
+            <a:endParaRPr lang="fr-FR" sz="1600" dirty="0"/>
+          </a:p>
+          <a:p>
+            <a:pPr lvl="0"/>
+            <a:endParaRPr lang="fr-FR" sz="1600" dirty="0"/>
+          </a:p>
+          <a:p>
+            <a:pPr lvl="0"/>
+            <a:r>
+              <a:rPr lang="fr-FR" sz="1600" dirty="0"/>
+              <a:t>Comment mesurer techniquement et prouver le "seuil" d'utilisation de l'IA sans que cela soit une usine à gaz ?</a:t>
+            </a:r>
+          </a:p>
+          <a:p>
+            <a:pPr lvl="0"/>
+            <a:r>
+              <a:rPr lang="fr-FR" sz="1600" dirty="0"/>
+              <a:t>Quel modèle économique adopter pour que la certification reste abordable pour les freelances ?</a:t>
+            </a:r>
           </a:p>
         </p:txBody>
       </p:sp>
@@ -8256,7 +8272,59 @@
                 <a:sym typeface="Calibri"/>
               </a:defRPr>
             </a:pPr>
-            <a:endParaRPr/>
+            <a:endParaRPr lang="fr-FR" dirty="0">
+              <a:latin typeface="+mn-lt"/>
+              <a:sym typeface="Calibri"/>
+            </a:endParaRPr>
+          </a:p>
+          <a:p>
+            <a:pPr>
+              <a:defRPr>
+                <a:latin typeface="+mn-lt"/>
+                <a:ea typeface="+mn-ea"/>
+                <a:cs typeface="+mn-cs"/>
+                <a:sym typeface="Calibri"/>
+              </a:defRPr>
+            </a:pPr>
+            <a:r>
+              <a:rPr lang="fr-FR" dirty="0">
+                <a:latin typeface="+mn-lt"/>
+                <a:sym typeface="Calibri"/>
+              </a:rPr>
+              <a:t>Créer une "Charte de Transparence" </a:t>
+            </a:r>
+          </a:p>
+          <a:p>
+            <a:pPr>
+              <a:defRPr>
+                <a:latin typeface="+mn-lt"/>
+                <a:ea typeface="+mn-ea"/>
+                <a:cs typeface="+mn-cs"/>
+                <a:sym typeface="Calibri"/>
+              </a:defRPr>
+            </a:pPr>
+            <a:endParaRPr lang="fr-FR" dirty="0">
+              <a:latin typeface="+mn-lt"/>
+              <a:sym typeface="Calibri"/>
+            </a:endParaRPr>
+          </a:p>
+          <a:p>
+            <a:pPr>
+              <a:defRPr>
+                <a:latin typeface="+mn-lt"/>
+                <a:ea typeface="+mn-ea"/>
+                <a:cs typeface="+mn-cs"/>
+                <a:sym typeface="Calibri"/>
+              </a:defRPr>
+            </a:pPr>
+            <a:r>
+              <a:rPr lang="fr-FR" dirty="0">
+                <a:latin typeface="+mn-lt"/>
+                <a:sym typeface="Calibri"/>
+              </a:rPr>
+              <a:t>Ajouter une simulation de prix (abonnement ou freemium) pour tester si le frein financier disparaît.</a:t>
+            </a:r>
+            <a:endParaRPr dirty="0"/>
           </a:p>
         </p:txBody>
       </p:sp>
@@ -8302,7 +8370,16 @@
           </a:lstStyle>
           <a:p>
             <a:r>
-              <a:t>Nos idées pour le prochain proto</a:t>
+              <a:rPr dirty="0"/>
+              <a:t>Nos </a:t>
+            </a:r>
+            <a:r>
+              <a:rPr dirty="0" err="1"/>
+              <a:t>idées</a:t>
+            </a:r>
+            <a:r>
+              <a:rPr dirty="0"/>
+              <a:t> pour le prochain proto</a:t>
             </a:r>
           </a:p>
         </p:txBody>
@@ -9207,8 +9284,8 @@
         </p:nvSpPr>
         <p:spPr>
           <a:xfrm>
-            <a:off x="749808" y="2193997"/>
-            <a:ext cx="5186020" cy="830993"/>
+            <a:off x="725017" y="2184917"/>
+            <a:ext cx="5198416" cy="1631212"/>
           </a:xfrm>
           <a:prstGeom prst="rect">
             <a:avLst/>
@@ -9240,10 +9317,280 @@
           <a:lstStyle/>
           <a:p>
             <a:r>
+              <a:rPr lang="fr-FR" sz="1200" dirty="0"/>
+              <a:t>La certification rassure immédiatement sur le professionnalisme et l'absence d'images volées ou "cheap«  dégagé par l’IA.</a:t>
+            </a:r>
+          </a:p>
+          <a:p>
+            <a:pPr lvl="0"/>
+            <a:r>
+              <a:rPr lang="fr-FR" sz="1200" dirty="0"/>
+              <a:t>(notamment dans le luxe) qui cherchent à préserver le savoir-faire humain.</a:t>
+            </a:r>
+          </a:p>
+          <a:p>
+            <a:pPr lvl="0"/>
+            <a:r>
+              <a:rPr lang="fr-FR" sz="1200" dirty="0"/>
+              <a:t>L'idée n'est pas d'être "</a:t>
+            </a:r>
+            <a:r>
+              <a:rPr lang="fr-FR" sz="1200" dirty="0" err="1"/>
+              <a:t>anti-IA</a:t>
+            </a:r>
+            <a:r>
+              <a:rPr lang="fr-FR" sz="1200" dirty="0"/>
+              <a:t>", mais de certifier l'humain </a:t>
+            </a:r>
+            <a:r>
+              <a:rPr lang="fr-FR" sz="1200" i="1" dirty="0"/>
+              <a:t>assisté</a:t>
+            </a:r>
+            <a:r>
+              <a:rPr lang="fr-FR" sz="1200" dirty="0"/>
+              <a:t> par l'IA ("Je mets de l'IA, mais je ne fais pas 100% IA").</a:t>
+            </a:r>
+          </a:p>
+          <a:p>
+            <a:pPr lvl="0"/>
+            <a:r>
+              <a:rPr lang="fr-FR" sz="1200" dirty="0"/>
+              <a:t>La protection des œuvres des artistes face aux reproductions générées par l'IA.</a:t>
+            </a:r>
+          </a:p>
+          <a:p>
+            <a:endParaRPr kumimoji="0" lang="fr-FR" sz="1600" b="0" i="0" u="none" strike="noStrike" cap="none" spc="0" normalizeH="0" baseline="0" dirty="0">
+              <a:ln>
+                <a:noFill/>
+              </a:ln>
+              <a:solidFill>
+                <a:srgbClr val="000000"/>
+              </a:solidFill>
+              <a:effectLst/>
+              <a:uFillTx/>
+              <a:latin typeface="+mj-lt"/>
+              <a:ea typeface="+mj-ea"/>
+              <a:cs typeface="+mj-cs"/>
+              <a:sym typeface="Helvetica"/>
+            </a:endParaRPr>
+          </a:p>
+        </p:txBody>
+      </p:sp>
+      <p:sp>
+        <p:nvSpPr>
+          <p:cNvPr id="4" name="ZoneTexte 3">
+            <a:extLst>
+              <a:ext uri="{FF2B5EF4-FFF2-40B4-BE49-F238E27FC236}">
+                <a16:creationId xmlns:a16="http://schemas.microsoft.com/office/drawing/2014/main" id="{2E28370F-6F46-8556-7DC0-23867E493795}"/>
+              </a:ext>
+            </a:extLst>
+          </p:cNvPr>
+          <p:cNvSpPr txBox="1"/>
+          <p:nvPr/>
+        </p:nvSpPr>
+        <p:spPr>
+          <a:xfrm>
+            <a:off x="6314290" y="2197225"/>
+            <a:ext cx="5127599" cy="1323439"/>
+          </a:xfrm>
+          <a:prstGeom prst="rect">
+            <a:avLst/>
+          </a:prstGeom>
+          <a:noFill/>
+          <a:ln w="12700" cap="flat">
+            <a:noFill/>
+            <a:miter lim="400000"/>
+          </a:ln>
+          <a:effectLst/>
+          <a:sp3d/>
+        </p:spPr>
+        <p:style>
+          <a:lnRef idx="0">
+            <a:scrgbClr r="0" g="0" b="0"/>
+          </a:lnRef>
+          <a:fillRef idx="0">
+            <a:scrgbClr r="0" g="0" b="0"/>
+          </a:fillRef>
+          <a:effectRef idx="0">
+            <a:scrgbClr r="0" g="0" b="0"/>
+          </a:effectRef>
+          <a:fontRef idx="none"/>
+        </p:style>
+        <p:txBody>
+          <a:bodyPr wrap="square">
+            <a:spAutoFit/>
+          </a:bodyPr>
+          <a:lstStyle/>
+          <a:p>
+            <a:pPr marL="342900" lvl="0" indent="-342900">
+              <a:buFont typeface="Arial" panose="020B0604020202020204" pitchFamily="34" charset="0"/>
+              <a:buChar char="•"/>
+            </a:pPr>
+            <a:r>
               <a:rPr lang="fr-FR" sz="1600" dirty="0"/>
-              <a:t>La certification rassure immédiatement sur le professionnalisme et l'absence d'images volées ou "cheap«  dégagé par l’IA.</a:t>
-            </a:r>
-            <a:endParaRPr kumimoji="0" lang="fr-FR" sz="1600" b="0" i="0" u="none" strike="noStrike" cap="none" spc="0" normalizeH="0" baseline="0" dirty="0">
+              <a:t>Le flou sur le "seuil" : à quel pourcentage d'utilisation de l'IA perd-on la certification ? La limite est dure à définir.</a:t>
+            </a:r>
+          </a:p>
+          <a:p>
+            <a:pPr marL="342900" lvl="0" indent="-342900">
+              <a:buFont typeface="Arial" panose="020B0604020202020204" pitchFamily="34" charset="0"/>
+              <a:buChar char="•"/>
+            </a:pPr>
+            <a:r>
+              <a:rPr lang="fr-FR" sz="1600" dirty="0"/>
+              <a:t>Le coût de la certification pour les indépendants (le photographe craint que ce soit trop cher).</a:t>
+            </a:r>
+          </a:p>
+        </p:txBody>
+      </p:sp>
+      <p:sp>
+        <p:nvSpPr>
+          <p:cNvPr id="6" name="Rectangle 5">
+            <a:extLst>
+              <a:ext uri="{FF2B5EF4-FFF2-40B4-BE49-F238E27FC236}">
+                <a16:creationId xmlns:a16="http://schemas.microsoft.com/office/drawing/2014/main" id="{7EC1E161-47B3-D668-8F0E-88671C2693F6}"/>
+              </a:ext>
+            </a:extLst>
+          </p:cNvPr>
+          <p:cNvSpPr/>
+          <p:nvPr/>
+        </p:nvSpPr>
+        <p:spPr>
+          <a:xfrm>
+            <a:off x="3099910" y="3825393"/>
+            <a:ext cx="459273" cy="385446"/>
+          </a:xfrm>
+          <a:prstGeom prst="rect">
+            <a:avLst/>
+          </a:prstGeom>
+          <a:noFill/>
+          <a:ln w="57150" cap="flat">
+            <a:solidFill>
+              <a:srgbClr val="FF0000"/>
+            </a:solidFill>
+            <a:prstDash val="solid"/>
+            <a:round/>
+          </a:ln>
+          <a:effectLst/>
+          <a:sp3d/>
+        </p:spPr>
+        <p:style>
+          <a:lnRef idx="0">
+            <a:scrgbClr r="0" g="0" b="0"/>
+          </a:lnRef>
+          <a:fillRef idx="0">
+            <a:scrgbClr r="0" g="0" b="0"/>
+          </a:fillRef>
+          <a:effectRef idx="0">
+            <a:scrgbClr r="0" g="0" b="0"/>
+          </a:effectRef>
+          <a:fontRef idx="none"/>
+        </p:style>
+        <p:txBody>
+          <a:bodyPr rot="0" spcFirstLastPara="1" vertOverflow="overflow" horzOverflow="overflow" vert="horz" wrap="square" lIns="45718" tIns="45718" rIns="45718" bIns="45718" numCol="1" spcCol="38100" rtlCol="0" anchor="ctr">
+            <a:spAutoFit/>
+          </a:bodyPr>
+          <a:lstStyle/>
+          <a:p>
+            <a:pPr marL="0" marR="0" indent="0" algn="l" defTabSz="914400" rtl="0" fontAlgn="auto" latinLnBrk="0" hangingPunct="0">
+              <a:lnSpc>
+                <a:spcPct val="100000"/>
+              </a:lnSpc>
+              <a:spcBef>
+                <a:spcPts val="0"/>
+              </a:spcBef>
+              <a:spcAft>
+                <a:spcPts val="0"/>
+              </a:spcAft>
+              <a:buClrTx/>
+              <a:buSzTx/>
+              <a:buFontTx/>
+              <a:buNone/>
+              <a:tabLst/>
+            </a:pPr>
+            <a:endParaRPr kumimoji="0" lang="fr-FR" sz="1800" b="0" i="0" u="none" strike="noStrike" cap="none" spc="0" normalizeH="0" baseline="0">
+              <a:ln>
+                <a:noFill/>
+              </a:ln>
+              <a:solidFill>
+                <a:srgbClr val="000000"/>
+              </a:solidFill>
+              <a:effectLst/>
+              <a:uFillTx/>
+              <a:latin typeface="+mj-lt"/>
+              <a:ea typeface="+mj-ea"/>
+              <a:cs typeface="+mj-cs"/>
+              <a:sym typeface="Helvetica"/>
+            </a:endParaRPr>
+          </a:p>
+        </p:txBody>
+      </p:sp>
+      <p:sp>
+        <p:nvSpPr>
+          <p:cNvPr id="8" name="Rectangle 7">
+            <a:extLst>
+              <a:ext uri="{FF2B5EF4-FFF2-40B4-BE49-F238E27FC236}">
+                <a16:creationId xmlns:a16="http://schemas.microsoft.com/office/drawing/2014/main" id="{81927D49-5CCF-2A6C-1F32-71E0AFC8D21B}"/>
+              </a:ext>
+            </a:extLst>
+          </p:cNvPr>
+          <p:cNvSpPr/>
+          <p:nvPr/>
+        </p:nvSpPr>
+        <p:spPr>
+          <a:xfrm>
+            <a:off x="4390313" y="3811481"/>
+            <a:ext cx="459273" cy="385446"/>
+          </a:xfrm>
+          <a:prstGeom prst="rect">
+            <a:avLst/>
+          </a:prstGeom>
+          <a:noFill/>
+          <a:ln w="57150" cap="flat">
+            <a:solidFill>
+              <a:srgbClr val="FF0000"/>
+            </a:solidFill>
+            <a:prstDash val="solid"/>
+            <a:round/>
+          </a:ln>
+          <a:effectLst/>
+          <a:sp3d/>
+        </p:spPr>
+        <p:style>
+          <a:lnRef idx="0">
+            <a:scrgbClr r="0" g="0" b="0"/>
+          </a:lnRef>
+          <a:fillRef idx="0">
+            <a:scrgbClr r="0" g="0" b="0"/>
+          </a:fillRef>
+          <a:effectRef idx="0">
+            <a:scrgbClr r="0" g="0" b="0"/>
+          </a:effectRef>
+          <a:fontRef idx="none"/>
+        </p:style>
+        <p:txBody>
+          <a:bodyPr rot="0" spcFirstLastPara="1" vertOverflow="overflow" horzOverflow="overflow" vert="horz" wrap="square" lIns="45718" tIns="45718" rIns="45718" bIns="45718" numCol="1" spcCol="38100" rtlCol="0" anchor="ctr">
+            <a:spAutoFit/>
+          </a:bodyPr>
+          <a:lstStyle/>
+          <a:p>
+            <a:pPr marL="0" marR="0" indent="0" algn="l" defTabSz="914400" rtl="0" fontAlgn="auto" latinLnBrk="0" hangingPunct="0">
+              <a:lnSpc>
+                <a:spcPct val="100000"/>
+              </a:lnSpc>
+              <a:spcBef>
+                <a:spcPts val="0"/>
+              </a:spcBef>
+              <a:spcAft>
+                <a:spcPts val="0"/>
+              </a:spcAft>
+              <a:buClrTx/>
+              <a:buSzTx/>
+              <a:buFontTx/>
+              <a:buNone/>
+              <a:tabLst/>
+            </a:pPr>
+            <a:endParaRPr kumimoji="0" lang="fr-FR" sz="1800" b="0" i="0" u="none" strike="noStrike" cap="none" spc="0" normalizeH="0" baseline="0">
               <a:ln>
                 <a:noFill/>
               </a:ln>
@@ -9388,7 +9735,7 @@
         </p:nvSpPr>
         <p:spPr>
           <a:xfrm>
-            <a:off x="566927" y="1755648"/>
+            <a:off x="566926" y="1507974"/>
             <a:ext cx="10874962" cy="186557"/>
           </a:xfrm>
           <a:prstGeom prst="rect">
@@ -9422,7 +9769,48 @@
           </a:lstStyle>
           <a:p>
             <a:r>
-              <a:t>Les tests ont peut-être bougé votre proposition de valeur.</a:t>
+              <a:rPr dirty="0"/>
+              <a:t>Les tests </a:t>
+            </a:r>
+            <a:r>
+              <a:rPr dirty="0" err="1"/>
+              <a:t>ont</a:t>
+            </a:r>
+            <a:r>
+              <a:rPr dirty="0"/>
+              <a:t> </a:t>
+            </a:r>
+            <a:r>
+              <a:rPr dirty="0" err="1"/>
+              <a:t>peut-être</a:t>
+            </a:r>
+            <a:r>
+              <a:rPr dirty="0"/>
+              <a:t> </a:t>
+            </a:r>
+            <a:r>
+              <a:rPr dirty="0" err="1"/>
+              <a:t>bougé</a:t>
+            </a:r>
+            <a:r>
+              <a:rPr dirty="0"/>
+              <a:t> </a:t>
+            </a:r>
+            <a:r>
+              <a:rPr dirty="0" err="1"/>
+              <a:t>votre</a:t>
+            </a:r>
+            <a:r>
+              <a:rPr dirty="0"/>
+              <a:t> proposition de </a:t>
+            </a:r>
+            <a:r>
+              <a:rPr dirty="0" err="1"/>
+              <a:t>valeur</a:t>
+            </a:r>
+            <a:r>
+              <a:rPr dirty="0"/>
+              <a:t>.</a:t>
             </a:r>
           </a:p>
         </p:txBody>
@@ -9462,7 +9850,42 @@
                 <a:sym typeface="Calibri"/>
               </a:defRPr>
             </a:pPr>
-            <a:endParaRPr/>
+            <a:endParaRPr lang="fr-FR" dirty="0">
+              <a:latin typeface="+mn-lt"/>
+              <a:sym typeface="Calibri"/>
+            </a:endParaRPr>
+          </a:p>
+          <a:p>
+            <a:pPr>
+              <a:defRPr>
+                <a:latin typeface="+mn-lt"/>
+                <a:ea typeface="+mn-ea"/>
+                <a:cs typeface="+mn-cs"/>
+                <a:sym typeface="Calibri"/>
+              </a:defRPr>
+            </a:pPr>
+            <a:endParaRPr lang="fr-FR" sz="1600" dirty="0">
+              <a:latin typeface="+mn-lt"/>
+              <a:sym typeface="Calibri"/>
+            </a:endParaRPr>
+          </a:p>
+          <a:p>
+            <a:pPr>
+              <a:defRPr>
+                <a:latin typeface="+mn-lt"/>
+                <a:ea typeface="+mn-ea"/>
+                <a:cs typeface="+mn-cs"/>
+                <a:sym typeface="Calibri"/>
+              </a:defRPr>
+            </a:pPr>
+            <a:r>
+              <a:rPr lang="fr-FR" sz="1600" dirty="0">
+                <a:latin typeface="+mn-lt"/>
+                <a:sym typeface="Calibri"/>
+              </a:rPr>
+              <a:t>Pour les créatifs indépendants qui ont besoin de justifier leurs tarifs, notre solution apporte un label valorisant le temps de réflexion humaine pour prouver leur authenticité face à l'IA.</a:t>
+            </a:r>
+            <a:endParaRPr sz="1600" dirty="0"/>
           </a:p>
         </p:txBody>
       </p:sp>
@@ -9508,6 +9931,7 @@
           </a:lstStyle>
           <a:p>
             <a:r>
+              <a:rPr dirty="0"/>
               <a:t>NOTRE PROPOSITION DE VALEUR (FIN J2)</a:t>
             </a:r>
           </a:p>
@@ -9568,8 +9992,8 @@
         </p:nvSpPr>
         <p:spPr>
           <a:xfrm>
-            <a:off x="4420513" y="2148839"/>
-            <a:ext cx="3350668" cy="1766081"/>
+            <a:off x="4320553" y="1710864"/>
+            <a:ext cx="3538193" cy="2361086"/>
           </a:xfrm>
           <a:prstGeom prst="rect">
             <a:avLst/>
@@ -9595,7 +10019,42 @@
                 <a:sym typeface="Calibri"/>
               </a:defRPr>
             </a:pPr>
-            <a:endParaRPr/>
+            <a:endParaRPr lang="fr-FR" sz="1400" dirty="0">
+              <a:latin typeface="+mn-lt"/>
+              <a:sym typeface="Calibri"/>
+            </a:endParaRPr>
+          </a:p>
+          <a:p>
+            <a:pPr>
+              <a:defRPr>
+                <a:latin typeface="+mn-lt"/>
+                <a:ea typeface="+mn-ea"/>
+                <a:cs typeface="+mn-cs"/>
+                <a:sym typeface="Calibri"/>
+              </a:defRPr>
+            </a:pPr>
+            <a:r>
+              <a:rPr lang="fr-FR" sz="1400" dirty="0">
+                <a:latin typeface="+mn-lt"/>
+                <a:sym typeface="Calibri"/>
+              </a:rPr>
+              <a:t>Les retours ont montré que la solution ne doit pas être perçue comme "</a:t>
+            </a:r>
+            <a:r>
+              <a:rPr lang="fr-FR" sz="1400" dirty="0" err="1">
+                <a:latin typeface="+mn-lt"/>
+                <a:sym typeface="Calibri"/>
+              </a:rPr>
+              <a:t>Anti-IA</a:t>
+            </a:r>
+            <a:r>
+              <a:rPr lang="fr-FR" sz="1400" dirty="0">
+                <a:latin typeface="+mn-lt"/>
+                <a:sym typeface="Calibri"/>
+              </a:rPr>
+              <a:t>", mais comme la garantie d'une "IA maîtrisée par l'humain". De plus, le label n'attire pas seulement pour des questions d'ego, mais parce qu'il permet de viser une clientèle plus haut de gamme (le luxe). Enfin, la question du seuil (la limite d'usage de l'IA) et le coût du label doivent être clarifiés.</a:t>
+            </a:r>
+            <a:endParaRPr sz="2000" dirty="0"/>
           </a:p>
         </p:txBody>
       </p:sp>
@@ -9607,7 +10066,7 @@
         </p:nvSpPr>
         <p:spPr>
           <a:xfrm>
-            <a:off x="4603393" y="2340100"/>
+            <a:off x="4597195" y="1750160"/>
             <a:ext cx="2984908" cy="147831"/>
           </a:xfrm>
           <a:prstGeom prst="rect">
@@ -9641,6 +10100,7 @@
           </a:lstStyle>
           <a:p>
             <a:r>
+              <a:rPr dirty="0"/>
               <a:t>CE QUE LES TESTS ONT CHANGÉ</a:t>
             </a:r>
           </a:p>
@@ -9701,8 +10161,8 @@
         </p:nvSpPr>
         <p:spPr>
           <a:xfrm>
-            <a:off x="8274101" y="2148839"/>
-            <a:ext cx="3350668" cy="1766081"/>
+            <a:off x="8274101" y="1061218"/>
+            <a:ext cx="3350668" cy="3010732"/>
           </a:xfrm>
           <a:prstGeom prst="rect">
             <a:avLst/>
@@ -9728,7 +10188,42 @@
                 <a:sym typeface="Calibri"/>
               </a:defRPr>
             </a:pPr>
-            <a:endParaRPr/>
+            <a:endParaRPr lang="fr-FR" sz="1600" b="1" dirty="0">
+              <a:latin typeface="+mn-lt"/>
+              <a:sym typeface="Calibri"/>
+            </a:endParaRPr>
+          </a:p>
+          <a:p>
+            <a:pPr>
+              <a:defRPr>
+                <a:latin typeface="+mn-lt"/>
+                <a:ea typeface="+mn-ea"/>
+                <a:cs typeface="+mn-cs"/>
+                <a:sym typeface="Calibri"/>
+              </a:defRPr>
+            </a:pPr>
+            <a:endParaRPr lang="fr-FR" sz="1600" b="1" dirty="0">
+              <a:latin typeface="+mn-lt"/>
+              <a:sym typeface="Calibri"/>
+            </a:endParaRPr>
+          </a:p>
+          <a:p>
+            <a:pPr>
+              <a:defRPr>
+                <a:latin typeface="+mn-lt"/>
+                <a:ea typeface="+mn-ea"/>
+                <a:cs typeface="+mn-cs"/>
+                <a:sym typeface="Calibri"/>
+              </a:defRPr>
+            </a:pPr>
+            <a:r>
+              <a:rPr lang="fr-FR" sz="1600" dirty="0">
+                <a:latin typeface="+mn-lt"/>
+                <a:sym typeface="Calibri"/>
+              </a:rPr>
+              <a:t>Pour les créatifs et les marques premium, notre label "Processus Créatif Éthique (PCE)" apporte une certification transparente sur le juste dosage entre savoir-faire humain et assistance IA. Contrairement à aujourd'hui, elle protège les artistes du plagiat, crédibilise leur démarche, et permet aux marques de garantir une image authentique à leurs clients.</a:t>
+            </a:r>
+            <a:endParaRPr sz="1600" dirty="0"/>
           </a:p>
         </p:txBody>
       </p:sp>
@@ -9740,8 +10235,8 @@
         </p:nvSpPr>
         <p:spPr>
           <a:xfrm>
-            <a:off x="8456979" y="2263900"/>
-            <a:ext cx="2984908" cy="300231"/>
+            <a:off x="8274100" y="1068246"/>
+            <a:ext cx="2984908" cy="338554"/>
           </a:xfrm>
           <a:prstGeom prst="rect">
             <a:avLst/>
@@ -9774,8 +10269,10 @@
           </a:lstStyle>
           <a:p>
             <a:r>
+              <a:rPr dirty="0"/>
               <a:t>NOTRE PROPOSITION DE VALEUR CONSOLIDÉE</a:t>
             </a:r>
+            <a:endParaRPr lang="fr-FR" dirty="0"/>
           </a:p>
         </p:txBody>
       </p:sp>
@@ -9814,7 +10311,75 @@
                 <a:sym typeface="Calibri"/>
               </a:defRPr>
             </a:pPr>
-            <a:endParaRPr/>
+            <a:endParaRPr lang="fr-FR" dirty="0">
+              <a:latin typeface="+mn-lt"/>
+              <a:sym typeface="Calibri"/>
+            </a:endParaRPr>
+          </a:p>
+          <a:p>
+            <a:pPr>
+              <a:defRPr>
+                <a:latin typeface="+mn-lt"/>
+                <a:ea typeface="+mn-ea"/>
+                <a:cs typeface="+mn-cs"/>
+                <a:sym typeface="Calibri"/>
+              </a:defRPr>
+            </a:pPr>
+            <a:endParaRPr lang="fr-FR" dirty="0">
+              <a:latin typeface="+mn-lt"/>
+              <a:sym typeface="Calibri"/>
+            </a:endParaRPr>
+          </a:p>
+          <a:p>
+            <a:pPr>
+              <a:defRPr>
+                <a:latin typeface="+mn-lt"/>
+                <a:ea typeface="+mn-ea"/>
+                <a:cs typeface="+mn-cs"/>
+                <a:sym typeface="Calibri"/>
+              </a:defRPr>
+            </a:pPr>
+            <a:endParaRPr lang="fr-FR" dirty="0">
+              <a:latin typeface="+mn-lt"/>
+              <a:sym typeface="Calibri"/>
+            </a:endParaRPr>
+          </a:p>
+          <a:p>
+            <a:pPr marL="342900" indent="-342900">
+              <a:buAutoNum type="arabicPeriod"/>
+              <a:defRPr>
+                <a:latin typeface="+mn-lt"/>
+                <a:ea typeface="+mn-ea"/>
+                <a:cs typeface="+mn-cs"/>
+                <a:sym typeface="Calibri"/>
+              </a:defRPr>
+            </a:pPr>
+            <a:r>
+              <a:rPr lang="fr-FR" dirty="0">
+                <a:latin typeface="+mn-lt"/>
+                <a:sym typeface="Calibri"/>
+              </a:rPr>
+              <a:t>Les créatifs / freelances (Modèle abonnement accessible + certification particulière à la demande) </a:t>
+            </a:r>
+          </a:p>
+          <a:p>
+            <a:pPr marL="342900" indent="-342900">
+              <a:buAutoNum type="arabicPeriod"/>
+              <a:defRPr>
+                <a:latin typeface="+mn-lt"/>
+                <a:ea typeface="+mn-ea"/>
+                <a:cs typeface="+mn-cs"/>
+                <a:sym typeface="Calibri"/>
+              </a:defRPr>
+            </a:pPr>
+            <a:r>
+              <a:rPr lang="fr-FR" dirty="0">
+                <a:latin typeface="+mn-lt"/>
+                <a:sym typeface="Calibri"/>
+              </a:rPr>
+              <a:t>Les marques et agences (B2B - Modèle Premium) : Les gros groupes (ex: LVMH, agences de pub) paient plus cher pour certifier leurs campagnes. Ils paient pour protéger leur image de marque. </a:t>
+            </a:r>
+            <a:endParaRPr dirty="0"/>
           </a:p>
         </p:txBody>
       </p:sp>

</xml_diff>